<commit_message>
Actualiza el equipo a cuatro integrantes
Retira a Choquehuanca Marrufo de la lista de integrantes, reparte sus
láminas del avance 2 entre los demás y regenera avance_2_ver_2.
</commit_message>
<xml_diff>
--- a/clase_entregables/avance_2_ver_2.pptx
+++ b/clase_entregables/avance_2_ver_2.pptx
@@ -516,7 +516,7 @@
           <a:lstStyle/>
           <a:p>
             <a:r>
-              <a:t>EXPOSITOR SUGERIDO: Liam Choquehuanca</a:t>
+              <a:t>EXPOSITOR SUGERIDO: Diego Damián</a:t>
             </a:r>
           </a:p>
           <a:p/>
@@ -834,7 +834,7 @@
           <a:lstStyle/>
           <a:p>
             <a:r>
-              <a:t>EXPOSITOR SUGERIDO: Apolo Villanueva</a:t>
+              <a:t>EXPOSITOR SUGERIDO: Jian Pier Campos</a:t>
             </a:r>
           </a:p>
           <a:p/>
@@ -1273,7 +1273,7 @@
           <a:lstStyle/>
           <a:p>
             <a:r>
-              <a:t>EXPOSITOR SUGERIDO: Liam Choquehuanca</a:t>
+              <a:t>EXPOSITOR SUGERIDO: Diego Damián</a:t>
             </a:r>
           </a:p>
           <a:p/>
@@ -1364,7 +1364,7 @@
           <a:lstStyle/>
           <a:p>
             <a:r>
-              <a:t>EXPOSITOR SUGERIDO: Liam Choquehuanca</a:t>
+              <a:t>EXPOSITOR SUGERIDO: Diego Damián</a:t>
             </a:r>
           </a:p>
           <a:p/>
@@ -1581,7 +1581,7 @@
           <a:lstStyle/>
           <a:p>
             <a:r>
-              <a:t>EXPOSITOR SUGERIDO: Diego Damián</a:t>
+              <a:t>EXPOSITOR SUGERIDO: Juan Franco Loayza</a:t>
             </a:r>
           </a:p>
           <a:p/>
@@ -1702,7 +1702,7 @@
           <a:lstStyle/>
           <a:p>
             <a:r>
-              <a:t>EXPOSITOR SUGERIDO: Diego Damián</a:t>
+              <a:t>EXPOSITOR SUGERIDO: Juan Franco Loayza</a:t>
             </a:r>
           </a:p>
           <a:p/>
@@ -1929,7 +1929,7 @@
           <a:lstStyle/>
           <a:p>
             <a:r>
-              <a:t>EXPOSITOR SUGERIDO: Juan Franco Loayza</a:t>
+              <a:t>EXPOSITOR SUGERIDO: Apolo Villanueva</a:t>
             </a:r>
           </a:p>
           <a:p/>
@@ -2045,7 +2045,7 @@
           <a:lstStyle/>
           <a:p>
             <a:r>
-              <a:t>EXPOSITOR SUGERIDO: Juan Franco Loayza</a:t>
+              <a:t>EXPOSITOR SUGERIDO: Apolo Villanueva</a:t>
             </a:r>
           </a:p>
           <a:p/>
@@ -5746,7 +5746,7 @@
                 </a:solidFill>
                 <a:latin typeface="Calibri"/>
               </a:rPr>
-              <a:t>Choquehuanca Marrufo, Liam Lennon  ·  Damián Valdivia, Diego Aarón  ·  Loayza Gerónimo, Juan Franco  ·  Villanueva Montalvo, Apolo Chris  ·  Campos Sulca, Jian Pier</a:t>
+              <a:t>Damián Valdivia, Diego Aarón  ·  Loayza Gerónimo, Juan Franco  ·  Villanueva Montalvo, Apolo Chris  ·  Campos Sulca, Jian Pier</a:t>
             </a:r>
           </a:p>
         </p:txBody>

</xml_diff>